<commit_message>
Tabuleiro interativo para jogar contra o modelo
Novo módulo tabuleiro.py: tabuleiro em JavaScript puro no Colab, com arrastar
e soltar, clique-clique, destaque de lances legais, animação do lance do modelo,
histórico e botões de nova partida, desfazer e trocar cores. O estado fica em
Python e a comunicação usa as callbacks do Colab. A seção 3.5 do notebook, o
slide 27 e o plano foram atualizados; a versão em texto continua como reserva.
</commit_message>
<xml_diff>
--- a/slides/attention_workshop.pptx
+++ b/slides/attention_workshop.pptx
@@ -2252,7 +2252,7 @@
               <a:rPr lang="en-US" dirty="0"/>
               <a:t>Tempo: 20 minutos (01:30 a 01:50). O treino da seção 3.2 já deve ter terminado durante o intervalo.
 Roteiro sugerido: gerar três partidas e observar em que lance cada uma se torna ilegal (3.3); variar a temperatura; medir a taxa de legalidade do próprio modelo e comparar com a do modelo de referência (3.4); jogar contra o modelo (3.5).
-Para jogar, a turma digita lances em notação algébrica. Quem não conhece a notação pode usar a tabela do slide anterior ou jogar aberturas conhecidas (1.e4, 2.Nf3, 3.Bc4). A seção 3.6 é um complemento para quem terminar antes.
+O tabuleiro da seção 3.5 é interativo: basta arrastar as peças (ou clicar na peça e depois na casa), e os lances legais ficam marcados. Quem preferir pode digitar em notação algébrica. Os lances do modelo aparecem em vermelho no histórico, e o painel mostra quantos deles foram legais na primeira tentativa. Vale sugerir que a turma jogue também contra o próprio modelo (trocando ref por modelo na célula) para comparar. A seção 3.6 é um complemento para quem terminar antes.
 Se o modelo de referência não estiver disponível, a seção 3.4 usa automaticamente o modelo treinado pela turma.</a:t>
             </a:r>
             <a:endParaRPr lang="en-US" dirty="0"/>
@@ -30470,7 +30470,7 @@
                 <a:ea typeface="Calibri" pitchFamily="34" charset="-122"/>
                 <a:cs typeface="Calibri" pitchFamily="34" charset="-120"/>
               </a:rPr>
-              <a:t>Lances em notação algébrica: e4, Nf3, exd5, O-O, Qxf7#. Digite “sair” para encerrar.</a:t>
+              <a:t>Arraste as peças ou clique na peça e depois na casa. Também é possível digitar o lance (e4, Nf3, O-O).</a:t>
             </a:r>
             <a:endParaRPr lang="en-US" sz="1600" dirty="0"/>
           </a:p>

</xml_diff>